<commit_message>
slides(wk13, wk14): match the #141 worksheet fixes; rebuild the two decks
- week13: the Trivy commands now match scan.sh / the worksheet — "${PWD}"
  (PowerShell cannot parse "$PWD:/src"), :latest tag and the severity filters
  (without them the hardened file showed 1 LOW finding, not the 0 Task 4
  expects). Split onto continuation lines so the code block no longer wraps
  mid-flag.
- week14: Gandalf -> Lakera Agent Breaker (gandalf.lakera.ai now redirects
  there): roadmap line, prompt-injection slide, game slide, deliverable, and
  the speaker notes. Also fixes "Gandalf + Tasks 1-2" (Task 2 is LLM05, not
  injection) and "replay your winning injection" -> the Task 1 / Task 2
  payloads, which is what worksheet Task 5 asks for.

Only week13.pptx and week14.pptx are rebuilt (build_all.js rewrites all 19;
the other 17 were restored unchanged). Page counts unchanged (15 / 16);
both edited slides checked rendered via LibreOffice.

Co-Authored-By: Claude Opus 5.5 <noreply@anthropic.com>
</commit_message>
<xml_diff>
--- a/slides/pptx/week13.pptx
+++ b/slides/pptx/week13.pptx
@@ -2124,7 +2124,7 @@
       </p:grpSpPr>
       <p:pic>
         <p:nvPicPr>
-          <p:cNvPr id="2" name="Image 0" descr="/private/tmp/claude-501/-Users-pop7-Library-CloudStorage-OneDrive-MonsterConnectCo--Ltd-Lecture-KOSEN69---software-security/e6d6556f-17de-403d-a9a0-cf2f846149b4/scratchpad/tree/slides/pptx/assets/logo-small.png">    </p:cNvPr>
+          <p:cNvPr id="2" name="Image 0" descr="/private/tmp/claude-501/-Users-pop7-Library-CloudStorage-OneDrive-MonsterConnectCo--Ltd-Lecture-KOSEN69---software-security/f63a82af-e1ad-40ed-89c4-03c6ca776e3f/scratchpad/fix6/KOSEN69 - software-security/slides/pptx/assets/logo-small.png">    </p:cNvPr>
           <p:cNvPicPr>
             <a:picLocks noChangeAspect="1"/>
           </p:cNvPicPr>
@@ -2524,7 +2524,7 @@
       </p:sp>
       <p:pic>
         <p:nvPicPr>
-          <p:cNvPr id="8" name="Image 1" descr="/private/tmp/claude-501/-Users-pop7-Library-CloudStorage-OneDrive-MonsterConnectCo--Ltd-Lecture-KOSEN69---software-security/e6d6556f-17de-403d-a9a0-cf2f846149b4/scratchpad/tree/slides/pptx/assets/logo-small.png">    </p:cNvPr>
+          <p:cNvPr id="8" name="Image 1" descr="/private/tmp/claude-501/-Users-pop7-Library-CloudStorage-OneDrive-MonsterConnectCo--Ltd-Lecture-KOSEN69---software-security/f63a82af-e1ad-40ed-89c4-03c6ca776e3f/scratchpad/fix6/KOSEN69 - software-security/slides/pptx/assets/logo-small.png">    </p:cNvPr>
           <p:cNvPicPr>
             <a:picLocks noChangeAspect="1"/>
           </p:cNvPicPr>
@@ -2733,7 +2733,7 @@
       </p:sp>
       <p:pic>
         <p:nvPicPr>
-          <p:cNvPr id="7" name="Image 2" descr="/private/tmp/claude-501/-Users-pop7-Library-CloudStorage-OneDrive-MonsterConnectCo--Ltd-Lecture-KOSEN69---software-security/e6d6556f-17de-403d-a9a0-cf2f846149b4/scratchpad/tree/slides/pptx/assets/logo-small.png">    </p:cNvPr>
+          <p:cNvPr id="7" name="Image 2" descr="/private/tmp/claude-501/-Users-pop7-Library-CloudStorage-OneDrive-MonsterConnectCo--Ltd-Lecture-KOSEN69---software-security/f63a82af-e1ad-40ed-89c4-03c6ca776e3f/scratchpad/fix6/KOSEN69 - software-security/slides/pptx/assets/logo-small.png">    </p:cNvPr>
           <p:cNvPicPr>
             <a:picLocks noChangeAspect="1"/>
           </p:cNvPicPr>
@@ -3159,7 +3159,7 @@
       </p:sp>
       <p:pic>
         <p:nvPicPr>
-          <p:cNvPr id="13" name="Image 1" descr="/private/tmp/claude-501/-Users-pop7-Library-CloudStorage-OneDrive-MonsterConnectCo--Ltd-Lecture-KOSEN69---software-security/e6d6556f-17de-403d-a9a0-cf2f846149b4/scratchpad/tree/slides/pptx/assets/logo-small.png">    </p:cNvPr>
+          <p:cNvPr id="13" name="Image 1" descr="/private/tmp/claude-501/-Users-pop7-Library-CloudStorage-OneDrive-MonsterConnectCo--Ltd-Lecture-KOSEN69---software-security/f63a82af-e1ad-40ed-89c4-03c6ca776e3f/scratchpad/fix6/KOSEN69 - software-security/slides/pptx/assets/logo-small.png">    </p:cNvPr>
           <p:cNvPicPr>
             <a:picLocks noChangeAspect="1"/>
           </p:cNvPicPr>
@@ -3544,7 +3544,7 @@
       </p:sp>
       <p:pic>
         <p:nvPicPr>
-          <p:cNvPr id="10" name="Image 1" descr="/private/tmp/claude-501/-Users-pop7-Library-CloudStorage-OneDrive-MonsterConnectCo--Ltd-Lecture-KOSEN69---software-security/e6d6556f-17de-403d-a9a0-cf2f846149b4/scratchpad/tree/slides/pptx/assets/logo-small.png">    </p:cNvPr>
+          <p:cNvPr id="10" name="Image 1" descr="/private/tmp/claude-501/-Users-pop7-Library-CloudStorage-OneDrive-MonsterConnectCo--Ltd-Lecture-KOSEN69---software-security/f63a82af-e1ad-40ed-89c4-03c6ca776e3f/scratchpad/fix6/KOSEN69 - software-security/slides/pptx/assets/logo-small.png">    </p:cNvPr>
           <p:cNvPicPr>
             <a:picLocks noChangeAspect="1"/>
           </p:cNvPicPr>
@@ -3845,7 +3845,7 @@
       </p:sp>
       <p:pic>
         <p:nvPicPr>
-          <p:cNvPr id="8" name="Image 1" descr="/private/tmp/claude-501/-Users-pop7-Library-CloudStorage-OneDrive-MonsterConnectCo--Ltd-Lecture-KOSEN69---software-security/e6d6556f-17de-403d-a9a0-cf2f846149b4/scratchpad/tree/slides/pptx/assets/logo-small.png">    </p:cNvPr>
+          <p:cNvPr id="8" name="Image 1" descr="/private/tmp/claude-501/-Users-pop7-Library-CloudStorage-OneDrive-MonsterConnectCo--Ltd-Lecture-KOSEN69---software-security/f63a82af-e1ad-40ed-89c4-03c6ca776e3f/scratchpad/fix6/KOSEN69 - software-security/slides/pptx/assets/logo-small.png">    </p:cNvPr>
           <p:cNvPicPr>
             <a:picLocks noChangeAspect="1"/>
           </p:cNvPicPr>
@@ -3979,7 +3979,7 @@
       </p:sp>
       <p:pic>
         <p:nvPicPr>
-          <p:cNvPr id="4" name="Image 0" descr="/private/tmp/claude-501/-Users-pop7-Library-CloudStorage-OneDrive-MonsterConnectCo--Ltd-Lecture-KOSEN69---software-security/e6d6556f-17de-403d-a9a0-cf2f846149b4/scratchpad/tree/slides/pptx/assets/logo-small.png">    </p:cNvPr>
+          <p:cNvPr id="4" name="Image 0" descr="/private/tmp/claude-501/-Users-pop7-Library-CloudStorage-OneDrive-MonsterConnectCo--Ltd-Lecture-KOSEN69---software-security/f63a82af-e1ad-40ed-89c4-03c6ca776e3f/scratchpad/fix6/KOSEN69 - software-security/slides/pptx/assets/logo-small.png">    </p:cNvPr>
           <p:cNvPicPr>
             <a:picLocks noChangeAspect="1"/>
           </p:cNvPicPr>
@@ -4322,7 +4322,7 @@
       </p:sp>
       <p:pic>
         <p:nvPicPr>
-          <p:cNvPr id="8" name="Image 1" descr="/private/tmp/claude-501/-Users-pop7-Library-CloudStorage-OneDrive-MonsterConnectCo--Ltd-Lecture-KOSEN69---software-security/e6d6556f-17de-403d-a9a0-cf2f846149b4/scratchpad/tree/slides/pptx/assets/logo-small.png">    </p:cNvPr>
+          <p:cNvPr id="8" name="Image 1" descr="/private/tmp/claude-501/-Users-pop7-Library-CloudStorage-OneDrive-MonsterConnectCo--Ltd-Lecture-KOSEN69---software-security/f63a82af-e1ad-40ed-89c4-03c6ca776e3f/scratchpad/fix6/KOSEN69 - software-security/slides/pptx/assets/logo-small.png">    </p:cNvPr>
           <p:cNvPicPr>
             <a:picLocks noChangeAspect="1"/>
           </p:cNvPicPr>
@@ -4623,7 +4623,7 @@
       </p:sp>
       <p:pic>
         <p:nvPicPr>
-          <p:cNvPr id="8" name="Image 1" descr="/private/tmp/claude-501/-Users-pop7-Library-CloudStorage-OneDrive-MonsterConnectCo--Ltd-Lecture-KOSEN69---software-security/e6d6556f-17de-403d-a9a0-cf2f846149b4/scratchpad/tree/slides/pptx/assets/logo-small.png">    </p:cNvPr>
+          <p:cNvPr id="8" name="Image 1" descr="/private/tmp/claude-501/-Users-pop7-Library-CloudStorage-OneDrive-MonsterConnectCo--Ltd-Lecture-KOSEN69---software-security/f63a82af-e1ad-40ed-89c4-03c6ca776e3f/scratchpad/fix6/KOSEN69 - software-security/slides/pptx/assets/logo-small.png">    </p:cNvPr>
           <p:cNvPicPr>
             <a:picLocks noChangeAspect="1"/>
           </p:cNvPicPr>
@@ -4924,7 +4924,7 @@
       </p:sp>
       <p:pic>
         <p:nvPicPr>
-          <p:cNvPr id="8" name="Image 1" descr="/private/tmp/claude-501/-Users-pop7-Library-CloudStorage-OneDrive-MonsterConnectCo--Ltd-Lecture-KOSEN69---software-security/e6d6556f-17de-403d-a9a0-cf2f846149b4/scratchpad/tree/slides/pptx/assets/logo-small.png">    </p:cNvPr>
+          <p:cNvPr id="8" name="Image 1" descr="/private/tmp/claude-501/-Users-pop7-Library-CloudStorage-OneDrive-MonsterConnectCo--Ltd-Lecture-KOSEN69---software-security/f63a82af-e1ad-40ed-89c4-03c6ca776e3f/scratchpad/fix6/KOSEN69 - software-security/slides/pptx/assets/logo-small.png">    </p:cNvPr>
           <p:cNvPicPr>
             <a:picLocks noChangeAspect="1"/>
           </p:cNvPicPr>
@@ -5334,7 +5334,7 @@
       </p:sp>
       <p:pic>
         <p:nvPicPr>
-          <p:cNvPr id="11" name="Image 1" descr="/private/tmp/claude-501/-Users-pop7-Library-CloudStorage-OneDrive-MonsterConnectCo--Ltd-Lecture-KOSEN69---software-security/e6d6556f-17de-403d-a9a0-cf2f846149b4/scratchpad/tree/slides/pptx/assets/logo-small.png">    </p:cNvPr>
+          <p:cNvPr id="11" name="Image 1" descr="/private/tmp/claude-501/-Users-pop7-Library-CloudStorage-OneDrive-MonsterConnectCo--Ltd-Lecture-KOSEN69---software-security/f63a82af-e1ad-40ed-89c4-03c6ca776e3f/scratchpad/fix6/KOSEN69 - software-security/slides/pptx/assets/logo-small.png">    </p:cNvPr>
           <p:cNvPicPr>
             <a:picLocks noChangeAspect="1"/>
           </p:cNvPicPr>
@@ -5635,7 +5635,7 @@
       </p:sp>
       <p:pic>
         <p:nvPicPr>
-          <p:cNvPr id="8" name="Image 1" descr="/private/tmp/claude-501/-Users-pop7-Library-CloudStorage-OneDrive-MonsterConnectCo--Ltd-Lecture-KOSEN69---software-security/e6d6556f-17de-403d-a9a0-cf2f846149b4/scratchpad/tree/slides/pptx/assets/logo-small.png">    </p:cNvPr>
+          <p:cNvPr id="8" name="Image 1" descr="/private/tmp/claude-501/-Users-pop7-Library-CloudStorage-OneDrive-MonsterConnectCo--Ltd-Lecture-KOSEN69---software-security/f63a82af-e1ad-40ed-89c4-03c6ca776e3f/scratchpad/fix6/KOSEN69 - software-security/slides/pptx/assets/logo-small.png">    </p:cNvPr>
           <p:cNvPicPr>
             <a:picLocks noChangeAspect="1"/>
           </p:cNvPicPr>
@@ -5936,7 +5936,7 @@
       </p:sp>
       <p:pic>
         <p:nvPicPr>
-          <p:cNvPr id="8" name="Image 1" descr="/private/tmp/claude-501/-Users-pop7-Library-CloudStorage-OneDrive-MonsterConnectCo--Ltd-Lecture-KOSEN69---software-security/e6d6556f-17de-403d-a9a0-cf2f846149b4/scratchpad/tree/slides/pptx/assets/logo-small.png">    </p:cNvPr>
+          <p:cNvPr id="8" name="Image 1" descr="/private/tmp/claude-501/-Users-pop7-Library-CloudStorage-OneDrive-MonsterConnectCo--Ltd-Lecture-KOSEN69---software-security/f63a82af-e1ad-40ed-89c4-03c6ca776e3f/scratchpad/fix6/KOSEN69 - software-security/slides/pptx/assets/logo-small.png">    </p:cNvPr>
           <p:cNvPicPr>
             <a:picLocks noChangeAspect="1"/>
           </p:cNvPicPr>
@@ -6089,11 +6089,11 @@
         <p:spPr>
           <a:xfrm>
             <a:off x="457200" y="1325880"/>
-            <a:ext cx="8229600" cy="932688"/>
+            <a:ext cx="8229600" cy="1591056"/>
           </a:xfrm>
           <a:prstGeom prst="roundRect">
             <a:avLst>
-              <a:gd name="adj" fmla="val 5882"/>
+              <a:gd name="adj" fmla="val 3448"/>
             </a:avLst>
           </a:prstGeom>
           <a:solidFill>
@@ -6116,7 +6116,7 @@
         <p:spPr>
           <a:xfrm>
             <a:off x="640080" y="1399032"/>
-            <a:ext cx="7863840" cy="786384"/>
+            <a:ext cx="7863840" cy="1444752"/>
           </a:xfrm>
           <a:prstGeom prst="rect">
             <a:avLst/>
@@ -6142,7 +6142,7 @@
                 <a:ea typeface="Courier New" pitchFamily="34" charset="-122"/>
                 <a:cs typeface="Courier New" pitchFamily="34" charset="-120"/>
               </a:rPr>
-              <a:t>docker run --rm -v "$PWD:/src" aquasec/trivy config /src                    # misconfig</a:t>
+              <a:t># misconfig scan (Dockerfiles)</a:t>
             </a:r>
             <a:endParaRPr lang="en-US" sz="1150" dirty="0"/>
           </a:p>
@@ -6159,7 +6159,7 @@
                 <a:ea typeface="Courier New" pitchFamily="34" charset="-122"/>
                 <a:cs typeface="Courier New" pitchFamily="34" charset="-120"/>
               </a:rPr>
-              <a:t>docker run --rm -v /var/run/docker.sock:/var/run/docker.sock \</a:t>
+              <a:t>docker run --rm -v "${PWD}:/src" aquasec/trivy:latest \</a:t>
             </a:r>
             <a:endParaRPr lang="en-US" sz="1150" dirty="0"/>
           </a:p>
@@ -6176,10 +6176,61 @@
                 <a:ea typeface="Courier New" pitchFamily="34" charset="-122"/>
                 <a:cs typeface="Courier New" pitchFamily="34" charset="-120"/>
               </a:rPr>
-              <a:t>  aquasec/trivy image week13-hardened:lab                              # image CVEs</a:t>
+              <a:t>  config --severity MEDIUM,HIGH,CRITICAL /src</a:t>
             </a:r>
             <a:endParaRPr lang="en-US" sz="1150" dirty="0"/>
           </a:p>
+          <a:p>
+            <a:pPr indent="0" marL="0">
+              <a:buNone/>
+            </a:pPr>
+            <a:r>
+              <a:rPr lang="en-US" sz="1150" dirty="0">
+                <a:solidFill>
+                  <a:srgbClr val="9FE7D6"/>
+                </a:solidFill>
+                <a:latin typeface="Courier New" pitchFamily="34" charset="0"/>
+                <a:ea typeface="Courier New" pitchFamily="34" charset="-122"/>
+                <a:cs typeface="Courier New" pitchFamily="34" charset="-120"/>
+              </a:rPr>
+              <a:t># image CVE scan</a:t>
+            </a:r>
+            <a:endParaRPr lang="en-US" sz="1150" dirty="0"/>
+          </a:p>
+          <a:p>
+            <a:pPr indent="0" marL="0">
+              <a:buNone/>
+            </a:pPr>
+            <a:r>
+              <a:rPr lang="en-US" sz="1150" dirty="0">
+                <a:solidFill>
+                  <a:srgbClr val="9FE7D6"/>
+                </a:solidFill>
+                <a:latin typeface="Courier New" pitchFamily="34" charset="0"/>
+                <a:ea typeface="Courier New" pitchFamily="34" charset="-122"/>
+                <a:cs typeface="Courier New" pitchFamily="34" charset="-120"/>
+              </a:rPr>
+              <a:t>docker run --rm -v /var/run/docker.sock:/var/run/docker.sock \</a:t>
+            </a:r>
+            <a:endParaRPr lang="en-US" sz="1150" dirty="0"/>
+          </a:p>
+          <a:p>
+            <a:pPr indent="0" marL="0">
+              <a:buNone/>
+            </a:pPr>
+            <a:r>
+              <a:rPr lang="en-US" sz="1150" dirty="0">
+                <a:solidFill>
+                  <a:srgbClr val="9FE7D6"/>
+                </a:solidFill>
+                <a:latin typeface="Courier New" pitchFamily="34" charset="0"/>
+                <a:ea typeface="Courier New" pitchFamily="34" charset="-122"/>
+                <a:cs typeface="Courier New" pitchFamily="34" charset="-120"/>
+              </a:rPr>
+              <a:t>  aquasec/trivy:latest image --severity HIGH,CRITICAL week13-hardened:lab</a:t>
+            </a:r>
+            <a:endParaRPr lang="en-US" sz="1150" dirty="0"/>
+          </a:p>
         </p:txBody>
       </p:sp>
       <p:sp>
@@ -6190,12 +6241,12 @@
         </p:nvSpPr>
         <p:spPr>
           <a:xfrm>
-            <a:off x="457200" y="2423160"/>
-            <a:ext cx="8229600" cy="1810512"/>
+            <a:off x="457200" y="3081528"/>
+            <a:ext cx="8229600" cy="987552"/>
           </a:xfrm>
           <a:prstGeom prst="roundRect">
             <a:avLst>
-              <a:gd name="adj" fmla="val 4040"/>
+              <a:gd name="adj" fmla="val 7407"/>
             </a:avLst>
           </a:prstGeom>
           <a:solidFill>
@@ -6219,8 +6270,8 @@
         </p:nvSpPr>
         <p:spPr>
           <a:xfrm>
-            <a:off x="731520" y="2532888"/>
-            <a:ext cx="7680960" cy="1591056"/>
+            <a:off x="731520" y="3191256"/>
+            <a:ext cx="7680960" cy="768096"/>
           </a:xfrm>
           <a:prstGeom prst="rect">
             <a:avLst/>
@@ -6254,83 +6305,41 @@
             </a:r>
             <a:endParaRPr lang="en-US" sz="1400" dirty="0"/>
           </a:p>
-          <a:p>
-            <a:pPr marL="342900" indent="-342900">
-              <a:spcAft>
-                <a:spcPts val="600"/>
-              </a:spcAft>
-              <a:buSzPct val="100000"/>
-              <a:buChar char="•"/>
-            </a:pPr>
-            <a:r>
-              <a:rPr lang="en-US" sz="1400" dirty="0">
-                <a:solidFill>
-                  <a:srgbClr val="1F2937"/>
+        </p:txBody>
+      </p:sp>
+      <p:sp>
+        <p:nvSpPr>
+          <p:cNvPr id="9" name="Text 6"/>
+          <p:cNvSpPr/>
+          <p:nvPr/>
+        </p:nvSpPr>
+        <p:spPr>
+          <a:xfrm>
+            <a:off x="457200" y="4800600"/>
+            <a:ext cx="6949440" cy="274320"/>
+          </a:xfrm>
+          <a:prstGeom prst="rect">
+            <a:avLst/>
+          </a:prstGeom>
+          <a:noFill/>
+          <a:ln/>
+        </p:spPr>
+        <p:txBody>
+          <a:bodyPr wrap="square" lIns="0" tIns="0" rIns="0" bIns="0" rtlCol="0" anchor="ctr"/>
+          <a:lstStyle/>
+          <a:p>
+            <a:pPr indent="0" marL="0">
+              <a:buNone/>
+            </a:pPr>
+            <a:r>
+              <a:rPr lang="en-US" sz="900" dirty="0">
+                <a:solidFill>
+                  <a:srgbClr val="64748B"/>
                 </a:solidFill>
                 <a:latin typeface="Calibri" pitchFamily="34" charset="0"/>
                 <a:ea typeface="Calibri" pitchFamily="34" charset="-122"/>
                 <a:cs typeface="Calibri" pitchFamily="34" charset="-120"/>
               </a:rPr>
-              <a:t>@sha256:... digest pins, not just a version tag — a tag can be repointed later, a digest can't</a:t>
-            </a:r>
-            <a:endParaRPr lang="en-US" sz="1400" dirty="0"/>
-          </a:p>
-          <a:p>
-            <a:pPr marL="342900" indent="-342900">
-              <a:spcAft>
-                <a:spcPts val="600"/>
-              </a:spcAft>
-              <a:buSzPct val="100000"/>
-              <a:buChar char="•"/>
-            </a:pPr>
-            <a:r>
-              <a:rPr lang="en-US" sz="1400" dirty="0">
-                <a:solidFill>
-                  <a:srgbClr val="1F2937"/>
-                </a:solidFill>
-                <a:latin typeface="Calibri" pitchFamily="34" charset="0"/>
-                <a:ea typeface="Calibri" pitchFamily="34" charset="-122"/>
-                <a:cs typeface="Calibri" pitchFamily="34" charset="-120"/>
-              </a:rPr>
-              <a:t>Re-scan to prove reduced findings</a:t>
-            </a:r>
-            <a:endParaRPr lang="en-US" sz="1400" dirty="0"/>
-          </a:p>
-        </p:txBody>
-      </p:sp>
-      <p:sp>
-        <p:nvSpPr>
-          <p:cNvPr id="9" name="Text 6"/>
-          <p:cNvSpPr/>
-          <p:nvPr/>
-        </p:nvSpPr>
-        <p:spPr>
-          <a:xfrm>
-            <a:off x="457200" y="4800600"/>
-            <a:ext cx="6949440" cy="274320"/>
-          </a:xfrm>
-          <a:prstGeom prst="rect">
-            <a:avLst/>
-          </a:prstGeom>
-          <a:noFill/>
-          <a:ln/>
-        </p:spPr>
-        <p:txBody>
-          <a:bodyPr wrap="square" lIns="0" tIns="0" rIns="0" bIns="0" rtlCol="0" anchor="ctr"/>
-          <a:lstStyle/>
-          <a:p>
-            <a:pPr indent="0" marL="0">
-              <a:buNone/>
-            </a:pPr>
-            <a:r>
-              <a:rPr lang="en-US" sz="900" dirty="0">
-                <a:solidFill>
-                  <a:srgbClr val="64748B"/>
-                </a:solidFill>
-                <a:latin typeface="Calibri" pitchFamily="34" charset="0"/>
-                <a:ea typeface="Calibri" pitchFamily="34" charset="-122"/>
-                <a:cs typeface="Calibri" pitchFamily="34" charset="-120"/>
-              </a:rPr>
               <a:t>Software Security · Week 13</a:t>
             </a:r>
             <a:endParaRPr lang="en-US" sz="900" dirty="0"/>
@@ -6339,7 +6348,7 @@
       </p:sp>
       <p:pic>
         <p:nvPicPr>
-          <p:cNvPr id="10" name="Image 1" descr="/private/tmp/claude-501/-Users-pop7-Library-CloudStorage-OneDrive-MonsterConnectCo--Ltd-Lecture-KOSEN69---software-security/e6d6556f-17de-403d-a9a0-cf2f846149b4/scratchpad/tree/slides/pptx/assets/logo-small.png">    </p:cNvPr>
+          <p:cNvPr id="10" name="Image 1" descr="/private/tmp/claude-501/-Users-pop7-Library-CloudStorage-OneDrive-MonsterConnectCo--Ltd-Lecture-KOSEN69---software-security/f63a82af-e1ad-40ed-89c4-03c6ca776e3f/scratchpad/fix6/KOSEN69 - software-security/slides/pptx/assets/logo-small.png">    </p:cNvPr>
           <p:cNvPicPr>
             <a:picLocks noChangeAspect="1"/>
           </p:cNvPicPr>
@@ -6492,11 +6501,11 @@
         <p:spPr>
           <a:xfrm>
             <a:off x="457200" y="1325880"/>
-            <a:ext cx="8229600" cy="987552"/>
+            <a:ext cx="8229600" cy="1810512"/>
           </a:xfrm>
           <a:prstGeom prst="roundRect">
             <a:avLst>
-              <a:gd name="adj" fmla="val 7407"/>
+              <a:gd name="adj" fmla="val 4040"/>
             </a:avLst>
           </a:prstGeom>
           <a:solidFill>
@@ -6521,7 +6530,7 @@
         <p:spPr>
           <a:xfrm>
             <a:off x="731520" y="1435608"/>
-            <a:ext cx="7680960" cy="768096"/>
+            <a:ext cx="7680960" cy="1591056"/>
           </a:xfrm>
           <a:prstGeom prst="rect">
             <a:avLst/>
@@ -6551,45 +6560,87 @@
                 <a:ea typeface="Calibri" pitchFamily="34" charset="-122"/>
                 <a:cs typeface="Calibri" pitchFamily="34" charset="-120"/>
               </a:rPr>
-              <a:t>Trivy only catches 3 of 6 planted defects (:latest, root user, secret-in-ENV) — COPY . ., chmod -R 777, and unpinned pip install need manual review, no rule fires</a:t>
+              <a:t>@sha256:... digest pins, not just a version tag — a tag can be repointed later, a digest can't</a:t>
             </a:r>
             <a:endParaRPr lang="en-US" sz="1400" dirty="0"/>
           </a:p>
-        </p:txBody>
-      </p:sp>
-      <p:sp>
-        <p:nvSpPr>
-          <p:cNvPr id="7" name="Text 4"/>
-          <p:cNvSpPr/>
-          <p:nvPr/>
-        </p:nvSpPr>
-        <p:spPr>
-          <a:xfrm>
-            <a:off x="457200" y="4800600"/>
-            <a:ext cx="6949440" cy="274320"/>
-          </a:xfrm>
-          <a:prstGeom prst="rect">
-            <a:avLst/>
-          </a:prstGeom>
-          <a:noFill/>
-          <a:ln/>
-        </p:spPr>
-        <p:txBody>
-          <a:bodyPr wrap="square" lIns="0" tIns="0" rIns="0" bIns="0" rtlCol="0" anchor="ctr"/>
-          <a:lstStyle/>
-          <a:p>
-            <a:pPr indent="0" marL="0">
-              <a:buNone/>
-            </a:pPr>
-            <a:r>
-              <a:rPr lang="en-US" sz="900" dirty="0">
-                <a:solidFill>
-                  <a:srgbClr val="64748B"/>
+          <a:p>
+            <a:pPr marL="342900" indent="-342900">
+              <a:spcAft>
+                <a:spcPts val="600"/>
+              </a:spcAft>
+              <a:buSzPct val="100000"/>
+              <a:buChar char="•"/>
+            </a:pPr>
+            <a:r>
+              <a:rPr lang="en-US" sz="1400" dirty="0">
+                <a:solidFill>
+                  <a:srgbClr val="1F2937"/>
                 </a:solidFill>
                 <a:latin typeface="Calibri" pitchFamily="34" charset="0"/>
                 <a:ea typeface="Calibri" pitchFamily="34" charset="-122"/>
                 <a:cs typeface="Calibri" pitchFamily="34" charset="-120"/>
               </a:rPr>
+              <a:t>Re-scan to prove reduced findings</a:t>
+            </a:r>
+            <a:endParaRPr lang="en-US" sz="1400" dirty="0"/>
+          </a:p>
+          <a:p>
+            <a:pPr marL="342900" indent="-342900">
+              <a:spcAft>
+                <a:spcPts val="600"/>
+              </a:spcAft>
+              <a:buSzPct val="100000"/>
+              <a:buChar char="•"/>
+            </a:pPr>
+            <a:r>
+              <a:rPr lang="en-US" sz="1400" dirty="0">
+                <a:solidFill>
+                  <a:srgbClr val="1F2937"/>
+                </a:solidFill>
+                <a:latin typeface="Calibri" pitchFamily="34" charset="0"/>
+                <a:ea typeface="Calibri" pitchFamily="34" charset="-122"/>
+                <a:cs typeface="Calibri" pitchFamily="34" charset="-120"/>
+              </a:rPr>
+              <a:t>Trivy only catches 3 of 6 planted defects (:latest, root user, secret-in-ENV) — COPY . ., chmod -R 777, and unpinned pip install need manual review, no rule fires</a:t>
+            </a:r>
+            <a:endParaRPr lang="en-US" sz="1400" dirty="0"/>
+          </a:p>
+        </p:txBody>
+      </p:sp>
+      <p:sp>
+        <p:nvSpPr>
+          <p:cNvPr id="7" name="Text 4"/>
+          <p:cNvSpPr/>
+          <p:nvPr/>
+        </p:nvSpPr>
+        <p:spPr>
+          <a:xfrm>
+            <a:off x="457200" y="4800600"/>
+            <a:ext cx="6949440" cy="274320"/>
+          </a:xfrm>
+          <a:prstGeom prst="rect">
+            <a:avLst/>
+          </a:prstGeom>
+          <a:noFill/>
+          <a:ln/>
+        </p:spPr>
+        <p:txBody>
+          <a:bodyPr wrap="square" lIns="0" tIns="0" rIns="0" bIns="0" rtlCol="0" anchor="ctr"/>
+          <a:lstStyle/>
+          <a:p>
+            <a:pPr indent="0" marL="0">
+              <a:buNone/>
+            </a:pPr>
+            <a:r>
+              <a:rPr lang="en-US" sz="900" dirty="0">
+                <a:solidFill>
+                  <a:srgbClr val="64748B"/>
+                </a:solidFill>
+                <a:latin typeface="Calibri" pitchFamily="34" charset="0"/>
+                <a:ea typeface="Calibri" pitchFamily="34" charset="-122"/>
+                <a:cs typeface="Calibri" pitchFamily="34" charset="-120"/>
+              </a:rPr>
               <a:t>Software Security · Week 13</a:t>
             </a:r>
             <a:endParaRPr lang="en-US" sz="900" dirty="0"/>
@@ -6598,7 +6649,7 @@
       </p:sp>
       <p:pic>
         <p:nvPicPr>
-          <p:cNvPr id="8" name="Image 1" descr="/private/tmp/claude-501/-Users-pop7-Library-CloudStorage-OneDrive-MonsterConnectCo--Ltd-Lecture-KOSEN69---software-security/e6d6556f-17de-403d-a9a0-cf2f846149b4/scratchpad/tree/slides/pptx/assets/logo-small.png">    </p:cNvPr>
+          <p:cNvPr id="8" name="Image 1" descr="/private/tmp/claude-501/-Users-pop7-Library-CloudStorage-OneDrive-MonsterConnectCo--Ltd-Lecture-KOSEN69---software-security/f63a82af-e1ad-40ed-89c4-03c6ca776e3f/scratchpad/fix6/KOSEN69 - software-security/slides/pptx/assets/logo-small.png">    </p:cNvPr>
           <p:cNvPicPr>
             <a:picLocks noChangeAspect="1"/>
           </p:cNvPicPr>

</xml_diff>